<commit_message>
docs: embed real Phoenix trace screenshot in README + deck; finalize deck build
- Capture a live multi-agent trace (LoRA corpus query) from Phoenix
  -> docs/images/phoenix-trace.png (Orchestrator -> Researcher/rag_search
  -> Reviewer -> ReviewGate waterfall, with per-span latency + tokens).
- README observability section: replace the placeholder note with the
  screenshot + a caption describing the span tree.
- Deck slide 8: replace the dashed placeholder box with the framed
  screenshot (accent border, noFill) + caption.
- Deck build hygiene (previously uncommitted): fix the GitHub URL
  (class-notes-rag -> multi-agent-research-assistant), fix the build output
  path (../Research-Assistant-Capstone.pptx), and track package.json +
  package-lock.json so `node build_deck.js` is reproducible.
- gitignore: node_modules/ and .playwright-mcp/ scratch output.
</commit_message>
<xml_diff>
--- a/docs/Research-Assistant-Capstone.pptx
+++ b/docs/Research-Assistant-Capstone.pptx
@@ -2456,7 +2456,7 @@
                 <a:ea typeface="Calibri" pitchFamily="34" charset="-122"/>
                 <a:cs typeface="Calibri" pitchFamily="34" charset="-120"/>
               </a:rPr>
-              <a:t>github.com/ZMalick/class-notes-rag  ·  research-assistant-969189630215.us-central1.run.app</a:t>
+              <a:t>github.com/ZMalick/multi-agent-research-assistant  ·  research-assistant-969189630215.us-central1.run.app</a:t>
             </a:r>
             <a:endParaRPr lang="en-US" sz="1400" dirty="0"/>
           </a:p>
@@ -5419,7 +5419,7 @@
                 <a:ea typeface="Calibri" pitchFamily="34" charset="-122"/>
                 <a:cs typeface="Calibri" pitchFamily="34" charset="-120"/>
               </a:rPr>
-              <a:t>github.com/ZMalick/class-notes-rag</a:t>
+              <a:t>github.com/ZMalick/multi-agent-research-assistant</a:t>
             </a:r>
             <a:endParaRPr lang="en-US" sz="2000" dirty="0"/>
           </a:p>
@@ -11621,43 +11621,62 @@
           </a:p>
         </p:txBody>
       </p:sp>
-      <p:sp>
-        <p:nvSpPr>
-          <p:cNvPr id="11" name="Shape 9"/>
-          <p:cNvSpPr/>
-          <p:nvPr/>
-        </p:nvSpPr>
-        <p:spPr>
-          <a:xfrm>
-            <a:off x="6217920" y="1645920"/>
-            <a:ext cx="5394960" cy="4251960"/>
-          </a:xfrm>
-          <a:prstGeom prst="roundRect">
-            <a:avLst>
-              <a:gd name="adj" fmla="val 1720"/>
-            </a:avLst>
-          </a:prstGeom>
-          <a:solidFill>
-            <a:srgbClr val="F4F7FF"/>
-          </a:solidFill>
+      <p:pic>
+        <p:nvPicPr>
+          <p:cNvPr id="11" name="Image 0" descr="../images/phoenix-trace.png">    </p:cNvPr>
+          <p:cNvPicPr>
+            <a:picLocks noChangeAspect="1"/>
+          </p:cNvPicPr>
+          <p:nvPr/>
+        </p:nvPicPr>
+        <p:blipFill>
+          <a:blip r:embed="rId1"/>
+          <a:stretch>
+            <a:fillRect/>
+          </a:stretch>
+        </p:blipFill>
+        <p:spPr>
+          <a:xfrm>
+            <a:off x="6217920" y="1828800"/>
+            <a:ext cx="5394960" cy="3374136"/>
+          </a:xfrm>
+          <a:prstGeom prst="rect">
+            <a:avLst/>
+          </a:prstGeom>
+        </p:spPr>
+      </p:pic>
+      <p:sp>
+        <p:nvSpPr>
+          <p:cNvPr id="12" name="Shape 9"/>
+          <p:cNvSpPr/>
+          <p:nvPr/>
+        </p:nvSpPr>
+        <p:spPr>
+          <a:xfrm>
+            <a:off x="6217920" y="1828800"/>
+            <a:ext cx="5394960" cy="3374136"/>
+          </a:xfrm>
+          <a:prstGeom prst="rect">
+            <a:avLst/>
+          </a:prstGeom>
           <a:ln w="19050">
             <a:solidFill>
               <a:srgbClr val="38BDF8"/>
             </a:solidFill>
-            <a:prstDash val="dash"/>
+            <a:prstDash val="solid"/>
           </a:ln>
         </p:spPr>
       </p:sp>
       <p:sp>
         <p:nvSpPr>
-          <p:cNvPr id="12" name="Text 10"/>
-          <p:cNvSpPr/>
-          <p:nvPr/>
-        </p:nvSpPr>
-        <p:spPr>
-          <a:xfrm>
-            <a:off x="6217920" y="3383280"/>
-            <a:ext cx="5394960" cy="457200"/>
+          <p:cNvPr id="13" name="Text 10"/>
+          <p:cNvSpPr/>
+          <p:nvPr/>
+        </p:nvSpPr>
+        <p:spPr>
+          <a:xfrm>
+            <a:off x="6217920" y="5303520"/>
+            <a:ext cx="5394960" cy="640080"/>
           </a:xfrm>
           <a:prstGeom prst="rect">
             <a:avLst/>
@@ -11673,7 +11692,7 @@
               <a:buNone/>
             </a:pPr>
             <a:r>
-              <a:rPr lang="en-US" sz="1500" b="1" dirty="0">
+              <a:rPr lang="en-US" sz="1100" i="1" dirty="0">
                 <a:solidFill>
                   <a:srgbClr val="64748B"/>
                 </a:solidFill>
@@ -11681,46 +11700,7 @@
                 <a:ea typeface="Calibri" pitchFamily="34" charset="-122"/>
                 <a:cs typeface="Calibri" pitchFamily="34" charset="-120"/>
               </a:rPr>
-              <a:t>[ Phoenix trace screenshot ]</a:t>
-            </a:r>
-            <a:endParaRPr lang="en-US" sz="1500" dirty="0"/>
-          </a:p>
-        </p:txBody>
-      </p:sp>
-      <p:sp>
-        <p:nvSpPr>
-          <p:cNvPr id="13" name="Text 11"/>
-          <p:cNvSpPr/>
-          <p:nvPr/>
-        </p:nvSpPr>
-        <p:spPr>
-          <a:xfrm>
-            <a:off x="6217920" y="3840480"/>
-            <a:ext cx="5394960" cy="457200"/>
-          </a:xfrm>
-          <a:prstGeom prst="rect">
-            <a:avLst/>
-          </a:prstGeom>
-          <a:noFill/>
-          <a:ln/>
-        </p:spPr>
-        <p:txBody>
-          <a:bodyPr wrap="square" lIns="0" tIns="0" rIns="0" bIns="0" rtlCol="0" anchor="ctr"/>
-          <a:lstStyle/>
-          <a:p>
-            <a:pPr algn="ctr" indent="0" marL="0">
-              <a:buNone/>
-            </a:pPr>
-            <a:r>
-              <a:rPr lang="en-US" sz="1100" i="1" dirty="0">
-                <a:solidFill>
-                  <a:srgbClr val="64748B"/>
-                </a:solidFill>
-                <a:latin typeface="Calibri" pitchFamily="34" charset="0"/>
-                <a:ea typeface="Calibri" pitchFamily="34" charset="-122"/>
-                <a:cs typeface="Calibri" pitchFamily="34" charset="-120"/>
-              </a:rPr>
-              <a:t>paste the trace waterfall captured during the demo recording</a:t>
+              <a:t>A real run traced end-to-end: Orchestrator → Researcher (rag_search) → Reviewer → ReviewGate, with latency + tokens per span.</a:t>
             </a:r>
             <a:endParaRPr lang="en-US" sz="1100" dirty="0"/>
           </a:p>
@@ -11728,7 +11708,7 @@
       </p:sp>
       <p:sp>
         <p:nvSpPr>
-          <p:cNvPr id="14" name="Shape 12"/>
+          <p:cNvPr id="14" name="Shape 11"/>
           <p:cNvSpPr/>
           <p:nvPr/>
         </p:nvSpPr>
@@ -11748,7 +11728,7 @@
       </p:sp>
       <p:sp>
         <p:nvSpPr>
-          <p:cNvPr id="15" name="Text 13"/>
+          <p:cNvPr id="15" name="Text 12"/>
           <p:cNvSpPr/>
           <p:nvPr/>
         </p:nvSpPr>
@@ -11787,7 +11767,7 @@
       </p:sp>
       <p:sp>
         <p:nvSpPr>
-          <p:cNvPr id="16" name="Text 14"/>
+          <p:cNvPr id="16" name="Text 13"/>
           <p:cNvSpPr/>
           <p:nvPr/>
         </p:nvSpPr>

</xml_diff>

<commit_message>
docs: finalize submission materials + ignore Office lock files
Add submission post, recording scenes/run sheet, and design Q&A; sync
deck (.pptx + build_deck.js) and session log. Ignore ~$* Office lock
files so an open deck doesn't show as untracked.
</commit_message>
<xml_diff>
--- a/docs/Research-Assistant-Capstone.pptx
+++ b/docs/Research-Assistant-Capstone.pptx
@@ -3936,7 +3936,7 @@
                 <a:ea typeface="Calibri" pitchFamily="34" charset="-122"/>
                 <a:cs typeface="Calibri" pitchFamily="34" charset="-120"/>
               </a:rPr>
-              <a:t>The Reviewer checks the retrieved evidence, not the draft’s claims — this caught a real hallucination during testing.</a:t>
+              <a:t>The Reviewer checks every claim in the draft against the retrieved evidence the tools captured — this caught a real hallucination during testing.</a:t>
             </a:r>
             <a:endParaRPr lang="en-US" sz="1350" dirty="0"/>
           </a:p>
@@ -9197,7 +9197,7 @@
                 <a:ea typeface="Calibri" pitchFamily="34" charset="-122"/>
                 <a:cs typeface="Calibri" pitchFamily="34" charset="-120"/>
               </a:rPr>
-              <a:t>pypdf → semantic chunks → Vertex embeddings → FAISS → cited retrieval</a:t>
+              <a:t>pypdf → 500-token windows → Vertex embeddings → FAISS → cited retrieval</a:t>
             </a:r>
             <a:endParaRPr lang="en-US" sz="1300" dirty="0"/>
           </a:p>

</xml_diff>